<commit_message>
Entrega Banner, Documentação e POO
</commit_message>
<xml_diff>
--- a/documentos/Banner_FECAP_ADS2_FrontLine_Projeto5.pptx
+++ b/documentos/Banner_FECAP_ADS2_FrontLine_Projeto5.pptx
@@ -162,7 +162,7 @@
 <file path=ppt/revisionInfo.xml><?xml version="1.0" encoding="utf-8"?>
 <p1510:revInfo xmlns:a="http://schemas.openxmlformats.org/drawingml/2006/main" xmlns:r="http://schemas.openxmlformats.org/officeDocument/2006/relationships" xmlns:p1510="http://schemas.microsoft.com/office/powerpoint/2015/10/main">
   <p1510:revLst>
-    <p1510:client id="{F95B8280-7232-4042-AE49-3905FBA244E4}" v="131" dt="2025-11-03T18:16:59.024"/>
+    <p1510:client id="{494946EF-F75B-4558-B093-56D0DB5ADD97}" v="13" dt="2025-11-10T22:51:45.242"/>
   </p1510:revLst>
 </p1510:revInfo>
 </file>
@@ -172,18 +172,18 @@
   <pc:docChgLst>
     <pc:chgData name="Enzo Ribeiro" userId="f9f7ea07fcd4c2ea" providerId="LiveId" clId="{CDAD0CA6-2812-4D57-8AB3-CC3992266768}"/>
     <pc:docChg chg="undo custSel modSld">
-      <pc:chgData name="Enzo Ribeiro" userId="f9f7ea07fcd4c2ea" providerId="LiveId" clId="{CDAD0CA6-2812-4D57-8AB3-CC3992266768}" dt="2025-11-03T18:17:27.741" v="933" actId="20577"/>
+      <pc:chgData name="Enzo Ribeiro" userId="f9f7ea07fcd4c2ea" providerId="LiveId" clId="{CDAD0CA6-2812-4D57-8AB3-CC3992266768}" dt="2025-11-10T22:56:30.764" v="939" actId="20577"/>
       <pc:docMkLst>
         <pc:docMk/>
       </pc:docMkLst>
       <pc:sldChg chg="addSp delSp modSp mod">
-        <pc:chgData name="Enzo Ribeiro" userId="f9f7ea07fcd4c2ea" providerId="LiveId" clId="{CDAD0CA6-2812-4D57-8AB3-CC3992266768}" dt="2025-11-03T18:17:27.741" v="933" actId="20577"/>
+        <pc:chgData name="Enzo Ribeiro" userId="f9f7ea07fcd4c2ea" providerId="LiveId" clId="{CDAD0CA6-2812-4D57-8AB3-CC3992266768}" dt="2025-11-10T22:56:30.764" v="939" actId="20577"/>
         <pc:sldMkLst>
           <pc:docMk/>
           <pc:sldMk cId="2544194372" sldId="260"/>
         </pc:sldMkLst>
         <pc:spChg chg="add del mod">
-          <ac:chgData name="Enzo Ribeiro" userId="f9f7ea07fcd4c2ea" providerId="LiveId" clId="{CDAD0CA6-2812-4D57-8AB3-CC3992266768}" dt="2025-11-03T04:39:57.096" v="297" actId="20577"/>
+          <ac:chgData name="Enzo Ribeiro" userId="f9f7ea07fcd4c2ea" providerId="LiveId" clId="{CDAD0CA6-2812-4D57-8AB3-CC3992266768}" dt="2025-11-10T22:56:30.764" v="939" actId="20577"/>
           <ac:spMkLst>
             <pc:docMk/>
             <pc:sldMk cId="2544194372" sldId="260"/>
@@ -191,7 +191,7 @@
           </ac:spMkLst>
         </pc:spChg>
         <pc:spChg chg="mod">
-          <ac:chgData name="Enzo Ribeiro" userId="f9f7ea07fcd4c2ea" providerId="LiveId" clId="{CDAD0CA6-2812-4D57-8AB3-CC3992266768}" dt="2025-11-03T18:17:27.741" v="933" actId="20577"/>
+          <ac:chgData name="Enzo Ribeiro" userId="f9f7ea07fcd4c2ea" providerId="LiveId" clId="{CDAD0CA6-2812-4D57-8AB3-CC3992266768}" dt="2025-11-03T17:51:38.825" v="733"/>
           <ac:spMkLst>
             <pc:docMk/>
             <pc:sldMk cId="2544194372" sldId="260"/>
@@ -199,7 +199,7 @@
           </ac:spMkLst>
         </pc:spChg>
         <pc:spChg chg="mod">
-          <ac:chgData name="Enzo Ribeiro" userId="f9f7ea07fcd4c2ea" providerId="LiveId" clId="{CDAD0CA6-2812-4D57-8AB3-CC3992266768}" dt="2025-11-03T17:23:16.233" v="351" actId="1035"/>
+          <ac:chgData name="Enzo Ribeiro" userId="f9f7ea07fcd4c2ea" providerId="LiveId" clId="{CDAD0CA6-2812-4D57-8AB3-CC3992266768}" dt="2025-11-10T22:51:45.242" v="921"/>
           <ac:spMkLst>
             <pc:docMk/>
             <pc:sldMk cId="2544194372" sldId="260"/>
@@ -207,7 +207,7 @@
           </ac:spMkLst>
         </pc:spChg>
         <pc:spChg chg="mod">
-          <ac:chgData name="Enzo Ribeiro" userId="f9f7ea07fcd4c2ea" providerId="LiveId" clId="{CDAD0CA6-2812-4D57-8AB3-CC3992266768}" dt="2025-11-03T17:23:56.305" v="379" actId="1035"/>
+          <ac:chgData name="Enzo Ribeiro" userId="f9f7ea07fcd4c2ea" providerId="LiveId" clId="{CDAD0CA6-2812-4D57-8AB3-CC3992266768}" dt="2025-11-10T22:51:36.639" v="920" actId="255"/>
           <ac:spMkLst>
             <pc:docMk/>
             <pc:sldMk cId="2544194372" sldId="260"/>
@@ -215,47 +215,31 @@
           </ac:spMkLst>
         </pc:spChg>
         <pc:spChg chg="add del mod">
-          <ac:chgData name="Enzo Ribeiro" userId="f9f7ea07fcd4c2ea" providerId="LiveId" clId="{CDAD0CA6-2812-4D57-8AB3-CC3992266768}" dt="2025-11-03T17:43:33.076" v="683"/>
-          <ac:spMkLst>
-            <pc:docMk/>
-            <pc:sldMk cId="2544194372" sldId="260"/>
-            <ac:spMk id="26" creationId="{E37996F7-C511-85CA-D9D4-CFCD943AFE1A}"/>
-          </ac:spMkLst>
-        </pc:spChg>
-        <pc:spChg chg="add mod">
-          <ac:chgData name="Enzo Ribeiro" userId="f9f7ea07fcd4c2ea" providerId="LiveId" clId="{CDAD0CA6-2812-4D57-8AB3-CC3992266768}" dt="2025-11-03T17:38:59.580" v="604" actId="1076"/>
+          <ac:chgData name="Enzo Ribeiro" userId="f9f7ea07fcd4c2ea" providerId="LiveId" clId="{CDAD0CA6-2812-4D57-8AB3-CC3992266768}" dt="2025-11-10T22:50:14.761" v="909" actId="478"/>
           <ac:spMkLst>
             <pc:docMk/>
             <pc:sldMk cId="2544194372" sldId="260"/>
             <ac:spMk id="27" creationId="{F9DE6C96-A6AC-EE22-5AB3-2A0A39CD0BF5}"/>
           </ac:spMkLst>
         </pc:spChg>
-        <pc:spChg chg="add mod">
-          <ac:chgData name="Enzo Ribeiro" userId="f9f7ea07fcd4c2ea" providerId="LiveId" clId="{CDAD0CA6-2812-4D57-8AB3-CC3992266768}" dt="2025-11-03T17:38:49.125" v="602" actId="1076"/>
+        <pc:spChg chg="add del mod">
+          <ac:chgData name="Enzo Ribeiro" userId="f9f7ea07fcd4c2ea" providerId="LiveId" clId="{CDAD0CA6-2812-4D57-8AB3-CC3992266768}" dt="2025-11-10T22:50:14.761" v="909" actId="478"/>
           <ac:spMkLst>
             <pc:docMk/>
             <pc:sldMk cId="2544194372" sldId="260"/>
             <ac:spMk id="28" creationId="{4EFC1E5D-2DD7-D82A-7F8A-A7903761A934}"/>
           </ac:spMkLst>
         </pc:spChg>
-        <pc:spChg chg="mod">
-          <ac:chgData name="Enzo Ribeiro" userId="f9f7ea07fcd4c2ea" providerId="LiveId" clId="{CDAD0CA6-2812-4D57-8AB3-CC3992266768}" dt="2025-11-03T18:16:59.024" v="928" actId="1076"/>
-          <ac:spMkLst>
-            <pc:docMk/>
-            <pc:sldMk cId="2544194372" sldId="260"/>
-            <ac:spMk id="29" creationId="{22108886-71AE-7425-406A-CC03C41D865B}"/>
-          </ac:spMkLst>
-        </pc:spChg>
-        <pc:spChg chg="add mod">
-          <ac:chgData name="Enzo Ribeiro" userId="f9f7ea07fcd4c2ea" providerId="LiveId" clId="{CDAD0CA6-2812-4D57-8AB3-CC3992266768}" dt="2025-11-03T17:38:26.083" v="601" actId="1076"/>
+        <pc:spChg chg="add del mod">
+          <ac:chgData name="Enzo Ribeiro" userId="f9f7ea07fcd4c2ea" providerId="LiveId" clId="{CDAD0CA6-2812-4D57-8AB3-CC3992266768}" dt="2025-11-10T22:50:14.761" v="909" actId="478"/>
           <ac:spMkLst>
             <pc:docMk/>
             <pc:sldMk cId="2544194372" sldId="260"/>
             <ac:spMk id="30" creationId="{1FD3AF51-EADC-FC07-52DA-E72DACA275EA}"/>
           </ac:spMkLst>
         </pc:spChg>
-        <pc:spChg chg="add mod">
-          <ac:chgData name="Enzo Ribeiro" userId="f9f7ea07fcd4c2ea" providerId="LiveId" clId="{CDAD0CA6-2812-4D57-8AB3-CC3992266768}" dt="2025-11-03T17:38:22.222" v="600" actId="1076"/>
+        <pc:spChg chg="add del mod">
+          <ac:chgData name="Enzo Ribeiro" userId="f9f7ea07fcd4c2ea" providerId="LiveId" clId="{CDAD0CA6-2812-4D57-8AB3-CC3992266768}" dt="2025-11-10T22:50:14.761" v="909" actId="478"/>
           <ac:spMkLst>
             <pc:docMk/>
             <pc:sldMk cId="2544194372" sldId="260"/>
@@ -263,43 +247,27 @@
           </ac:spMkLst>
         </pc:spChg>
         <pc:spChg chg="add del mod">
-          <ac:chgData name="Enzo Ribeiro" userId="f9f7ea07fcd4c2ea" providerId="LiveId" clId="{CDAD0CA6-2812-4D57-8AB3-CC3992266768}" dt="2025-11-03T17:43:33.074" v="681" actId="478"/>
-          <ac:spMkLst>
-            <pc:docMk/>
-            <pc:sldMk cId="2544194372" sldId="260"/>
-            <ac:spMk id="32" creationId="{CED85D07-CD88-278F-924F-8F4EF682E5F1}"/>
-          </ac:spMkLst>
-        </pc:spChg>
-        <pc:spChg chg="add del">
-          <ac:chgData name="Enzo Ribeiro" userId="f9f7ea07fcd4c2ea" providerId="LiveId" clId="{CDAD0CA6-2812-4D57-8AB3-CC3992266768}" dt="2025-11-03T17:43:38.464" v="685" actId="22"/>
-          <ac:spMkLst>
-            <pc:docMk/>
-            <pc:sldMk cId="2544194372" sldId="260"/>
-            <ac:spMk id="34" creationId="{E344C42B-E91C-B910-61BA-4D436036B9E8}"/>
-          </ac:spMkLst>
-        </pc:spChg>
-        <pc:spChg chg="add del mod">
-          <ac:chgData name="Enzo Ribeiro" userId="f9f7ea07fcd4c2ea" providerId="LiveId" clId="{CDAD0CA6-2812-4D57-8AB3-CC3992266768}" dt="2025-11-03T17:47:32.992" v="729" actId="1076"/>
+          <ac:chgData name="Enzo Ribeiro" userId="f9f7ea07fcd4c2ea" providerId="LiveId" clId="{CDAD0CA6-2812-4D57-8AB3-CC3992266768}" dt="2025-11-10T22:50:08.029" v="908" actId="478"/>
           <ac:spMkLst>
             <pc:docMk/>
             <pc:sldMk cId="2544194372" sldId="260"/>
             <ac:spMk id="35" creationId="{833FE777-126C-65F4-4FBD-F2F4E06331ED}"/>
           </ac:spMkLst>
         </pc:spChg>
-        <pc:spChg chg="add mod">
-          <ac:chgData name="Enzo Ribeiro" userId="f9f7ea07fcd4c2ea" providerId="LiveId" clId="{CDAD0CA6-2812-4D57-8AB3-CC3992266768}" dt="2025-11-03T17:44:14.787" v="696"/>
+        <pc:spChg chg="add del">
+          <ac:chgData name="Enzo Ribeiro" userId="f9f7ea07fcd4c2ea" providerId="LiveId" clId="{CDAD0CA6-2812-4D57-8AB3-CC3992266768}" dt="2025-11-10T22:50:20.949" v="911" actId="22"/>
           <ac:spMkLst>
             <pc:docMk/>
             <pc:sldMk cId="2544194372" sldId="260"/>
-            <ac:spMk id="36" creationId="{E7ADD341-38FE-C8A6-2636-7F8105CC39C4}"/>
+            <ac:spMk id="37" creationId="{8C61F510-9BE3-FBD1-7EB7-6564B90E1A76}"/>
           </ac:spMkLst>
         </pc:spChg>
         <pc:spChg chg="add mod">
-          <ac:chgData name="Enzo Ribeiro" userId="f9f7ea07fcd4c2ea" providerId="LiveId" clId="{CDAD0CA6-2812-4D57-8AB3-CC3992266768}" dt="2025-11-03T17:44:34.629" v="716"/>
+          <ac:chgData name="Enzo Ribeiro" userId="f9f7ea07fcd4c2ea" providerId="LiveId" clId="{CDAD0CA6-2812-4D57-8AB3-CC3992266768}" dt="2025-11-10T22:51:15.206" v="918" actId="1076"/>
           <ac:spMkLst>
             <pc:docMk/>
             <pc:sldMk cId="2544194372" sldId="260"/>
-            <ac:spMk id="37" creationId="{833FE777-126C-65F4-4FBD-F2F4E06331ED}"/>
+            <ac:spMk id="38" creationId="{E7416FEB-3776-3D09-AC3F-C74620691E78}"/>
           </ac:spMkLst>
         </pc:spChg>
         <pc:spChg chg="mod">
@@ -310,8 +278,8 @@
             <ac:spMk id="4100" creationId="{00000000-0000-0000-0000-000000000000}"/>
           </ac:spMkLst>
         </pc:spChg>
-        <pc:spChg chg="mod">
-          <ac:chgData name="Enzo Ribeiro" userId="f9f7ea07fcd4c2ea" providerId="LiveId" clId="{CDAD0CA6-2812-4D57-8AB3-CC3992266768}" dt="2025-11-03T17:44:01.863" v="693" actId="20577"/>
+        <pc:spChg chg="del mod">
+          <ac:chgData name="Enzo Ribeiro" userId="f9f7ea07fcd4c2ea" providerId="LiveId" clId="{CDAD0CA6-2812-4D57-8AB3-CC3992266768}" dt="2025-11-10T22:50:04.174" v="905" actId="478"/>
           <ac:spMkLst>
             <pc:docMk/>
             <pc:sldMk cId="2544194372" sldId="260"/>
@@ -335,23 +303,23 @@
           </ac:spMkLst>
         </pc:spChg>
         <pc:picChg chg="add mod">
-          <ac:chgData name="Enzo Ribeiro" userId="f9f7ea07fcd4c2ea" providerId="LiveId" clId="{CDAD0CA6-2812-4D57-8AB3-CC3992266768}" dt="2025-11-03T18:12:21.112" v="822" actId="571"/>
+          <ac:chgData name="Enzo Ribeiro" userId="f9f7ea07fcd4c2ea" providerId="LiveId" clId="{CDAD0CA6-2812-4D57-8AB3-CC3992266768}" dt="2025-11-10T22:41:31.092" v="841" actId="571"/>
           <ac:picMkLst>
             <pc:docMk/>
             <pc:sldMk cId="2544194372" sldId="260"/>
-            <ac:picMk id="3" creationId="{02687CBE-B0A7-0F32-46A0-52AB2B649A1C}"/>
+            <ac:picMk id="3" creationId="{95536DBE-A6BE-343B-FFEA-14EC2DBB1B13}"/>
           </ac:picMkLst>
         </pc:picChg>
         <pc:picChg chg="mod">
-          <ac:chgData name="Enzo Ribeiro" userId="f9f7ea07fcd4c2ea" providerId="LiveId" clId="{CDAD0CA6-2812-4D57-8AB3-CC3992266768}" dt="2025-11-03T17:56:30.973" v="787" actId="1076"/>
+          <ac:chgData name="Enzo Ribeiro" userId="f9f7ea07fcd4c2ea" providerId="LiveId" clId="{CDAD0CA6-2812-4D57-8AB3-CC3992266768}" dt="2025-11-10T22:41:36.325" v="843" actId="1076"/>
           <ac:picMkLst>
             <pc:docMk/>
             <pc:sldMk cId="2544194372" sldId="260"/>
             <ac:picMk id="6" creationId="{F65B9183-D015-4EDA-BC8C-5077C4505C15}"/>
           </ac:picMkLst>
         </pc:picChg>
-        <pc:picChg chg="add mod">
-          <ac:chgData name="Enzo Ribeiro" userId="f9f7ea07fcd4c2ea" providerId="LiveId" clId="{CDAD0CA6-2812-4D57-8AB3-CC3992266768}" dt="2025-11-03T17:37:45.518" v="591" actId="14100"/>
+        <pc:picChg chg="add del mod">
+          <ac:chgData name="Enzo Ribeiro" userId="f9f7ea07fcd4c2ea" providerId="LiveId" clId="{CDAD0CA6-2812-4D57-8AB3-CC3992266768}" dt="2025-11-10T22:50:14.761" v="909" actId="478"/>
           <ac:picMkLst>
             <pc:docMk/>
             <pc:sldMk cId="2544194372" sldId="260"/>
@@ -359,7 +327,7 @@
           </ac:picMkLst>
         </pc:picChg>
         <pc:picChg chg="mod">
-          <ac:chgData name="Enzo Ribeiro" userId="f9f7ea07fcd4c2ea" providerId="LiveId" clId="{CDAD0CA6-2812-4D57-8AB3-CC3992266768}" dt="2025-11-03T18:16:59.024" v="928" actId="1076"/>
+          <ac:chgData name="Enzo Ribeiro" userId="f9f7ea07fcd4c2ea" providerId="LiveId" clId="{CDAD0CA6-2812-4D57-8AB3-CC3992266768}" dt="2025-11-10T22:55:30.918" v="934" actId="1076"/>
           <ac:picMkLst>
             <pc:docMk/>
             <pc:sldMk cId="2544194372" sldId="260"/>
@@ -367,7 +335,7 @@
           </ac:picMkLst>
         </pc:picChg>
         <pc:picChg chg="mod">
-          <ac:chgData name="Enzo Ribeiro" userId="f9f7ea07fcd4c2ea" providerId="LiveId" clId="{CDAD0CA6-2812-4D57-8AB3-CC3992266768}" dt="2025-11-03T18:16:59.024" v="928" actId="1076"/>
+          <ac:chgData name="Enzo Ribeiro" userId="f9f7ea07fcd4c2ea" providerId="LiveId" clId="{CDAD0CA6-2812-4D57-8AB3-CC3992266768}" dt="2025-11-10T22:55:28.769" v="933" actId="1076"/>
           <ac:picMkLst>
             <pc:docMk/>
             <pc:sldMk cId="2544194372" sldId="260"/>
@@ -375,7 +343,7 @@
           </ac:picMkLst>
         </pc:picChg>
         <pc:picChg chg="mod">
-          <ac:chgData name="Enzo Ribeiro" userId="f9f7ea07fcd4c2ea" providerId="LiveId" clId="{CDAD0CA6-2812-4D57-8AB3-CC3992266768}" dt="2025-11-03T18:16:59.024" v="928" actId="1076"/>
+          <ac:chgData name="Enzo Ribeiro" userId="f9f7ea07fcd4c2ea" providerId="LiveId" clId="{CDAD0CA6-2812-4D57-8AB3-CC3992266768}" dt="2025-11-10T22:55:23.612" v="932" actId="1076"/>
           <ac:picMkLst>
             <pc:docMk/>
             <pc:sldMk cId="2544194372" sldId="260"/>
@@ -383,7 +351,7 @@
           </ac:picMkLst>
         </pc:picChg>
         <pc:picChg chg="mod">
-          <ac:chgData name="Enzo Ribeiro" userId="f9f7ea07fcd4c2ea" providerId="LiveId" clId="{CDAD0CA6-2812-4D57-8AB3-CC3992266768}" dt="2025-11-03T18:16:59.024" v="928" actId="1076"/>
+          <ac:chgData name="Enzo Ribeiro" userId="f9f7ea07fcd4c2ea" providerId="LiveId" clId="{CDAD0CA6-2812-4D57-8AB3-CC3992266768}" dt="2025-11-10T22:54:46.545" v="926" actId="1076"/>
           <ac:picMkLst>
             <pc:docMk/>
             <pc:sldMk cId="2544194372" sldId="260"/>
@@ -391,55 +359,63 @@
           </ac:picMkLst>
         </pc:picChg>
         <pc:picChg chg="mod">
-          <ac:chgData name="Enzo Ribeiro" userId="f9f7ea07fcd4c2ea" providerId="LiveId" clId="{CDAD0CA6-2812-4D57-8AB3-CC3992266768}" dt="2025-11-03T18:16:59.024" v="928" actId="1076"/>
+          <ac:chgData name="Enzo Ribeiro" userId="f9f7ea07fcd4c2ea" providerId="LiveId" clId="{CDAD0CA6-2812-4D57-8AB3-CC3992266768}" dt="2025-11-10T22:55:09.352" v="929" actId="1076"/>
           <ac:picMkLst>
             <pc:docMk/>
             <pc:sldMk cId="2544194372" sldId="260"/>
             <ac:picMk id="15" creationId="{31366770-2457-D40F-603F-BB4428389EC6}"/>
           </ac:picMkLst>
         </pc:picChg>
+        <pc:picChg chg="add mod">
+          <ac:chgData name="Enzo Ribeiro" userId="f9f7ea07fcd4c2ea" providerId="LiveId" clId="{CDAD0CA6-2812-4D57-8AB3-CC3992266768}" dt="2025-11-10T22:41:31.092" v="841" actId="571"/>
+          <ac:picMkLst>
+            <pc:docMk/>
+            <pc:sldMk cId="2544194372" sldId="260"/>
+            <ac:picMk id="16" creationId="{A932CAEA-8383-AEB6-E990-CDC34FFC06A3}"/>
+          </ac:picMkLst>
+        </pc:picChg>
         <pc:picChg chg="mod">
-          <ac:chgData name="Enzo Ribeiro" userId="f9f7ea07fcd4c2ea" providerId="LiveId" clId="{CDAD0CA6-2812-4D57-8AB3-CC3992266768}" dt="2025-11-03T18:16:59.024" v="928" actId="1076"/>
+          <ac:chgData name="Enzo Ribeiro" userId="f9f7ea07fcd4c2ea" providerId="LiveId" clId="{CDAD0CA6-2812-4D57-8AB3-CC3992266768}" dt="2025-11-10T22:54:18.116" v="923" actId="1076"/>
           <ac:picMkLst>
             <pc:docMk/>
             <pc:sldMk cId="2544194372" sldId="260"/>
             <ac:picMk id="17" creationId="{BF4471B5-57EB-4844-928D-DCF9ED7AF6F5}"/>
           </ac:picMkLst>
         </pc:picChg>
-        <pc:picChg chg="del">
-          <ac:chgData name="Enzo Ribeiro" userId="f9f7ea07fcd4c2ea" providerId="LiveId" clId="{CDAD0CA6-2812-4D57-8AB3-CC3992266768}" dt="2025-11-03T17:51:55.905" v="734" actId="478"/>
+        <pc:picChg chg="add mod">
+          <ac:chgData name="Enzo Ribeiro" userId="f9f7ea07fcd4c2ea" providerId="LiveId" clId="{CDAD0CA6-2812-4D57-8AB3-CC3992266768}" dt="2025-11-10T22:41:31.092" v="841" actId="571"/>
           <ac:picMkLst>
             <pc:docMk/>
             <pc:sldMk cId="2544194372" sldId="260"/>
-            <ac:picMk id="18" creationId="{6D783549-32E2-3701-9536-85EC637BA269}"/>
+            <ac:picMk id="18" creationId="{372CD4F5-E218-18CC-F840-4FDF6578709F}"/>
           </ac:picMkLst>
         </pc:picChg>
-        <pc:picChg chg="del mod">
-          <ac:chgData name="Enzo Ribeiro" userId="f9f7ea07fcd4c2ea" providerId="LiveId" clId="{CDAD0CA6-2812-4D57-8AB3-CC3992266768}" dt="2025-11-03T18:10:51.972" v="795" actId="478"/>
+        <pc:picChg chg="mod">
+          <ac:chgData name="Enzo Ribeiro" userId="f9f7ea07fcd4c2ea" providerId="LiveId" clId="{CDAD0CA6-2812-4D57-8AB3-CC3992266768}" dt="2025-11-10T22:54:43.851" v="925" actId="1076"/>
           <ac:picMkLst>
             <pc:docMk/>
             <pc:sldMk cId="2544194372" sldId="260"/>
             <ac:picMk id="19" creationId="{1652BFF4-CD39-4D8B-CDB6-2EEBEA3ABE34}"/>
           </ac:picMkLst>
         </pc:picChg>
-        <pc:picChg chg="add mod">
-          <ac:chgData name="Enzo Ribeiro" userId="f9f7ea07fcd4c2ea" providerId="LiveId" clId="{CDAD0CA6-2812-4D57-8AB3-CC3992266768}" dt="2025-11-03T17:39:14.052" v="605" actId="1076"/>
+        <pc:picChg chg="add del mod">
+          <ac:chgData name="Enzo Ribeiro" userId="f9f7ea07fcd4c2ea" providerId="LiveId" clId="{CDAD0CA6-2812-4D57-8AB3-CC3992266768}" dt="2025-11-10T22:50:14.761" v="909" actId="478"/>
           <ac:picMkLst>
             <pc:docMk/>
             <pc:sldMk cId="2544194372" sldId="260"/>
             <ac:picMk id="20" creationId="{91AD46E0-7E4A-4BF4-4C3A-8FC981CEA3AF}"/>
           </ac:picMkLst>
         </pc:picChg>
-        <pc:picChg chg="del">
-          <ac:chgData name="Enzo Ribeiro" userId="f9f7ea07fcd4c2ea" providerId="LiveId" clId="{CDAD0CA6-2812-4D57-8AB3-CC3992266768}" dt="2025-11-03T17:52:19.989" v="745" actId="478"/>
+        <pc:picChg chg="add mod">
+          <ac:chgData name="Enzo Ribeiro" userId="f9f7ea07fcd4c2ea" providerId="LiveId" clId="{CDAD0CA6-2812-4D57-8AB3-CC3992266768}" dt="2025-11-10T22:41:31.092" v="841" actId="571"/>
           <ac:picMkLst>
             <pc:docMk/>
             <pc:sldMk cId="2544194372" sldId="260"/>
-            <ac:picMk id="21" creationId="{F1356FB8-9ED6-A85E-476B-90F186519F55}"/>
+            <ac:picMk id="21" creationId="{A8A462D9-542F-7C09-1BC4-6743BD57130A}"/>
           </ac:picMkLst>
         </pc:picChg>
-        <pc:picChg chg="add mod">
-          <ac:chgData name="Enzo Ribeiro" userId="f9f7ea07fcd4c2ea" providerId="LiveId" clId="{CDAD0CA6-2812-4D57-8AB3-CC3992266768}" dt="2025-11-03T17:39:17.054" v="606" actId="1076"/>
+        <pc:picChg chg="add del mod">
+          <ac:chgData name="Enzo Ribeiro" userId="f9f7ea07fcd4c2ea" providerId="LiveId" clId="{CDAD0CA6-2812-4D57-8AB3-CC3992266768}" dt="2025-11-10T22:50:14.761" v="909" actId="478"/>
           <ac:picMkLst>
             <pc:docMk/>
             <pc:sldMk cId="2544194372" sldId="260"/>
@@ -447,7 +423,15 @@
           </ac:picMkLst>
         </pc:picChg>
         <pc:picChg chg="add mod">
-          <ac:chgData name="Enzo Ribeiro" userId="f9f7ea07fcd4c2ea" providerId="LiveId" clId="{CDAD0CA6-2812-4D57-8AB3-CC3992266768}" dt="2025-11-03T17:39:27.066" v="608" actId="1076"/>
+          <ac:chgData name="Enzo Ribeiro" userId="f9f7ea07fcd4c2ea" providerId="LiveId" clId="{CDAD0CA6-2812-4D57-8AB3-CC3992266768}" dt="2025-11-10T22:55:52.613" v="936" actId="14100"/>
+          <ac:picMkLst>
+            <pc:docMk/>
+            <pc:sldMk cId="2544194372" sldId="260"/>
+            <ac:picMk id="24" creationId="{F2004384-96DB-EA09-D0EF-B0661EFA7B1C}"/>
+          </ac:picMkLst>
+        </pc:picChg>
+        <pc:picChg chg="add del mod">
+          <ac:chgData name="Enzo Ribeiro" userId="f9f7ea07fcd4c2ea" providerId="LiveId" clId="{CDAD0CA6-2812-4D57-8AB3-CC3992266768}" dt="2025-11-10T22:50:05.359" v="906" actId="478"/>
           <ac:picMkLst>
             <pc:docMk/>
             <pc:sldMk cId="2544194372" sldId="260"/>
@@ -455,15 +439,31 @@
           </ac:picMkLst>
         </pc:picChg>
         <pc:picChg chg="add mod">
-          <ac:chgData name="Enzo Ribeiro" userId="f9f7ea07fcd4c2ea" providerId="LiveId" clId="{CDAD0CA6-2812-4D57-8AB3-CC3992266768}" dt="2025-11-03T18:17:00.385" v="929" actId="1076"/>
+          <ac:chgData name="Enzo Ribeiro" userId="f9f7ea07fcd4c2ea" providerId="LiveId" clId="{CDAD0CA6-2812-4D57-8AB3-CC3992266768}" dt="2025-11-10T22:56:02.919" v="938" actId="1076"/>
+          <ac:picMkLst>
+            <pc:docMk/>
+            <pc:sldMk cId="2544194372" sldId="260"/>
+            <ac:picMk id="32" creationId="{613634C8-BDB1-7310-58D3-404A9B6F74C6}"/>
+          </ac:picMkLst>
+        </pc:picChg>
+        <pc:picChg chg="add mod">
+          <ac:chgData name="Enzo Ribeiro" userId="f9f7ea07fcd4c2ea" providerId="LiveId" clId="{CDAD0CA6-2812-4D57-8AB3-CC3992266768}" dt="2025-11-10T22:56:00.400" v="937" actId="1076"/>
+          <ac:picMkLst>
+            <pc:docMk/>
+            <pc:sldMk cId="2544194372" sldId="260"/>
+            <ac:picMk id="34" creationId="{9E7FDCD3-D33A-A6FE-C2B8-AA4BA081B2AC}"/>
+          </ac:picMkLst>
+        </pc:picChg>
+        <pc:picChg chg="add mod">
+          <ac:chgData name="Enzo Ribeiro" userId="f9f7ea07fcd4c2ea" providerId="LiveId" clId="{CDAD0CA6-2812-4D57-8AB3-CC3992266768}" dt="2025-11-10T22:55:45.160" v="935" actId="1076"/>
           <ac:picMkLst>
             <pc:docMk/>
             <pc:sldMk cId="2544194372" sldId="260"/>
             <ac:picMk id="39" creationId="{47EC7B2E-1438-6CA5-CD4E-2C1A1D0E8A4D}"/>
           </ac:picMkLst>
         </pc:picChg>
-        <pc:picChg chg="add mod">
-          <ac:chgData name="Enzo Ribeiro" userId="f9f7ea07fcd4c2ea" providerId="LiveId" clId="{CDAD0CA6-2812-4D57-8AB3-CC3992266768}" dt="2025-11-03T18:17:07.748" v="931" actId="1076"/>
+        <pc:picChg chg="add del mod">
+          <ac:chgData name="Enzo Ribeiro" userId="f9f7ea07fcd4c2ea" providerId="LiveId" clId="{CDAD0CA6-2812-4D57-8AB3-CC3992266768}" dt="2025-11-10T22:43:57.740" v="854" actId="478"/>
           <ac:picMkLst>
             <pc:docMk/>
             <pc:sldMk cId="2544194372" sldId="260"/>
@@ -471,75 +471,19 @@
           </ac:picMkLst>
         </pc:picChg>
         <pc:picChg chg="add del mod">
-          <ac:chgData name="Enzo Ribeiro" userId="f9f7ea07fcd4c2ea" providerId="LiveId" clId="{CDAD0CA6-2812-4D57-8AB3-CC3992266768}" dt="2025-11-03T18:17:02.848" v="930" actId="1076"/>
+          <ac:chgData name="Enzo Ribeiro" userId="f9f7ea07fcd4c2ea" providerId="LiveId" clId="{CDAD0CA6-2812-4D57-8AB3-CC3992266768}" dt="2025-11-10T22:41:52.286" v="845" actId="478"/>
           <ac:picMkLst>
             <pc:docMk/>
             <pc:sldMk cId="2544194372" sldId="260"/>
             <ac:picMk id="43" creationId="{89F40BDF-BBD6-AB2A-4AFA-121BD6878340}"/>
           </ac:picMkLst>
         </pc:picChg>
-        <pc:picChg chg="add mod">
-          <ac:chgData name="Enzo Ribeiro" userId="f9f7ea07fcd4c2ea" providerId="LiveId" clId="{CDAD0CA6-2812-4D57-8AB3-CC3992266768}" dt="2025-11-03T18:17:11.109" v="932" actId="1076"/>
+        <pc:picChg chg="add del mod">
+          <ac:chgData name="Enzo Ribeiro" userId="f9f7ea07fcd4c2ea" providerId="LiveId" clId="{CDAD0CA6-2812-4D57-8AB3-CC3992266768}" dt="2025-11-10T22:46:15.778" v="889" actId="478"/>
           <ac:picMkLst>
             <pc:docMk/>
             <pc:sldMk cId="2544194372" sldId="260"/>
             <ac:picMk id="45" creationId="{3A7CD76A-527F-6733-744A-F5AB970881FC}"/>
-          </ac:picMkLst>
-        </pc:picChg>
-        <pc:picChg chg="del">
-          <ac:chgData name="Enzo Ribeiro" userId="f9f7ea07fcd4c2ea" providerId="LiveId" clId="{CDAD0CA6-2812-4D57-8AB3-CC3992266768}" dt="2025-11-03T17:52:16.503" v="739" actId="478"/>
-          <ac:picMkLst>
-            <pc:docMk/>
-            <pc:sldMk cId="2544194372" sldId="260"/>
-            <ac:picMk id="49" creationId="{8E417FFA-3A80-0922-B813-237FD58D7D31}"/>
-          </ac:picMkLst>
-        </pc:picChg>
-        <pc:picChg chg="del">
-          <ac:chgData name="Enzo Ribeiro" userId="f9f7ea07fcd4c2ea" providerId="LiveId" clId="{CDAD0CA6-2812-4D57-8AB3-CC3992266768}" dt="2025-11-03T17:52:15.809" v="738" actId="478"/>
-          <ac:picMkLst>
-            <pc:docMk/>
-            <pc:sldMk cId="2544194372" sldId="260"/>
-            <ac:picMk id="51" creationId="{B738E67A-B274-5DF8-B9F3-9D3786D351B5}"/>
-          </ac:picMkLst>
-        </pc:picChg>
-        <pc:picChg chg="del">
-          <ac:chgData name="Enzo Ribeiro" userId="f9f7ea07fcd4c2ea" providerId="LiveId" clId="{CDAD0CA6-2812-4D57-8AB3-CC3992266768}" dt="2025-11-03T17:52:18.407" v="742" actId="478"/>
-          <ac:picMkLst>
-            <pc:docMk/>
-            <pc:sldMk cId="2544194372" sldId="260"/>
-            <ac:picMk id="53" creationId="{8E652B56-3614-D555-14EB-CF7818249A83}"/>
-          </ac:picMkLst>
-        </pc:picChg>
-        <pc:picChg chg="del">
-          <ac:chgData name="Enzo Ribeiro" userId="f9f7ea07fcd4c2ea" providerId="LiveId" clId="{CDAD0CA6-2812-4D57-8AB3-CC3992266768}" dt="2025-11-03T17:52:17.486" v="741" actId="478"/>
-          <ac:picMkLst>
-            <pc:docMk/>
-            <pc:sldMk cId="2544194372" sldId="260"/>
-            <ac:picMk id="55" creationId="{E959B3AA-39C3-5770-B50E-8051B104CAD7}"/>
-          </ac:picMkLst>
-        </pc:picChg>
-        <pc:picChg chg="del">
-          <ac:chgData name="Enzo Ribeiro" userId="f9f7ea07fcd4c2ea" providerId="LiveId" clId="{CDAD0CA6-2812-4D57-8AB3-CC3992266768}" dt="2025-11-03T17:52:18.953" v="743" actId="478"/>
-          <ac:picMkLst>
-            <pc:docMk/>
-            <pc:sldMk cId="2544194372" sldId="260"/>
-            <ac:picMk id="57" creationId="{0466FA70-F8D4-3A38-017F-54D92B813AC6}"/>
-          </ac:picMkLst>
-        </pc:picChg>
-        <pc:picChg chg="del">
-          <ac:chgData name="Enzo Ribeiro" userId="f9f7ea07fcd4c2ea" providerId="LiveId" clId="{CDAD0CA6-2812-4D57-8AB3-CC3992266768}" dt="2025-11-03T17:52:17.019" v="740" actId="478"/>
-          <ac:picMkLst>
-            <pc:docMk/>
-            <pc:sldMk cId="2544194372" sldId="260"/>
-            <ac:picMk id="59" creationId="{B9591974-087D-8CB2-9488-DC83918AB8EE}"/>
-          </ac:picMkLst>
-        </pc:picChg>
-        <pc:picChg chg="del">
-          <ac:chgData name="Enzo Ribeiro" userId="f9f7ea07fcd4c2ea" providerId="LiveId" clId="{CDAD0CA6-2812-4D57-8AB3-CC3992266768}" dt="2025-11-03T17:52:19.427" v="744" actId="478"/>
-          <ac:picMkLst>
-            <pc:docMk/>
-            <pc:sldMk cId="2544194372" sldId="260"/>
-            <ac:picMk id="4099" creationId="{DC769455-D84B-7CDB-9BC7-563FFA1CD8B1}"/>
           </ac:picMkLst>
         </pc:picChg>
       </pc:sldChg>
@@ -4634,62 +4578,6 @@
       </p:sp>
       <p:sp>
         <p:nvSpPr>
-          <p:cNvPr id="4102" name="TextBox 8"/>
-          <p:cNvSpPr txBox="1">
-            <a:spLocks noChangeArrowheads="1"/>
-          </p:cNvSpPr>
-          <p:nvPr/>
-        </p:nvSpPr>
-        <p:spPr bwMode="auto">
-          <a:xfrm>
-            <a:off x="690522" y="4992304"/>
-            <a:ext cx="13284851" cy="646331"/>
-          </a:xfrm>
-          <a:prstGeom prst="rect">
-            <a:avLst/>
-          </a:prstGeom>
-          <a:noFill/>
-          <a:ln>
-            <a:noFill/>
-          </a:ln>
-          <a:extLst>
-            <a:ext uri="{909E8E84-426E-40DD-AFC4-6F175D3DCCD1}">
-              <a14:hiddenFill xmlns:a14="http://schemas.microsoft.com/office/drawing/2010/main">
-                <a:solidFill>
-                  <a:srgbClr val="FFFFFF"/>
-                </a:solidFill>
-              </a14:hiddenFill>
-            </a:ext>
-            <a:ext uri="{91240B29-F687-4F45-9708-019B960494DF}">
-              <a14:hiddenLine xmlns:a14="http://schemas.microsoft.com/office/drawing/2010/main" w="9525">
-                <a:solidFill>
-                  <a:srgbClr val="000000"/>
-                </a:solidFill>
-                <a:miter lim="800000"/>
-                <a:headEnd/>
-                <a:tailEnd/>
-              </a14:hiddenLine>
-            </a:ext>
-          </a:extLst>
-        </p:spPr>
-        <p:txBody>
-          <a:bodyPr wrap="square">
-            <a:spAutoFit/>
-          </a:bodyPr>
-          <a:lstStyle/>
-          <a:p>
-            <a:pPr algn="just" defTabSz="1678349" eaLnBrk="1" hangingPunct="1"/>
-            <a:r>
-              <a:rPr lang="pt-BR" sz="3600" b="1" dirty="0">
-                <a:ea typeface="ＭＳ Ｐゴシック" pitchFamily="34" charset="-128"/>
-              </a:rPr>
-              <a:t>Sobre a equipe</a:t>
-            </a:r>
-          </a:p>
-        </p:txBody>
-      </p:sp>
-      <p:sp>
-        <p:nvSpPr>
           <p:cNvPr id="4104" name="Rectangle 13"/>
           <p:cNvSpPr>
             <a:spLocks noChangeArrowheads="1"/>
@@ -4972,7 +4860,7 @@
         <p:spPr bwMode="auto">
           <a:xfrm>
             <a:off x="14653154" y="4992305"/>
-            <a:ext cx="13284851" cy="4524124"/>
+            <a:ext cx="13284851" cy="4370235"/>
           </a:xfrm>
           <a:prstGeom prst="rect">
             <a:avLst/>
@@ -5029,13 +4917,6 @@
               <a:rPr lang="pt-BR" sz="2666" dirty="0"/>
               <a:t>	</a:t>
             </a:r>
-          </a:p>
-          <a:p>
-            <a:pPr algn="just" defTabSz="1678349" eaLnBrk="1" hangingPunct="1">
-              <a:spcAft>
-                <a:spcPts val="1200"/>
-              </a:spcAft>
-            </a:pPr>
             <a:r>
               <a:rPr lang="pt-BR" sz="2400" dirty="0"/>
               <a:t>  O Instituto Alma realizava diversas ações solidárias e projetos sociais, porém não possuía um site para divulgar suas atividades, facilitar doações ou manter transparência com a comunidade. A ausência de uma plataforma digital dificultava a comunicação, o alcance de novos apoiadores e o registro organizado das iniciativas do Instituto. Sem um canal centralizado, muitas informações sobre eventos e campanhas eram dispersas ou de difícil acesso, limitando o engajamento e a participação da comunidade. Além disso, a falta de visibilidade online impedia que o Instituto ampliasse seu impacto e fortalecesse sua rede de voluntários e parceiros.</a:t>
@@ -5072,7 +4953,7 @@
         <p:spPr bwMode="auto">
           <a:xfrm>
             <a:off x="630353" y="34849791"/>
-            <a:ext cx="13318910" cy="4175438"/>
+            <a:ext cx="13318910" cy="3806107"/>
           </a:xfrm>
           <a:prstGeom prst="rect">
             <a:avLst/>
@@ -5131,7 +5012,7 @@
             </a:r>
             <a:r>
               <a:rPr lang="pt-BR" sz="2400" dirty="0"/>
-              <a:t>  Para resolver o problema da ausência de presença digital do Instituto Alma, desenvolvemos um site completo e funcional. A plataforma apresenta informações sobre o Instituto, incluindo missão, visão e histórico, além de divulgar suas atividades e eventos sociais. Possui uma área dedicada a doações, garantindo transparência e facilidade para os contribuintes, e um canal de ouvidoria para receber sugestões e feedbacks da comunidade. Também conta com uma área administrativa, permitindo o gerenciamento eficiente de conteúdos, eventos e doações. Com essa solução, o Instituto Alma passa a integrar comunicação, gestão e engajamento em uma única plataforma, ampliando seu alcance e fortalecendo sua presença digital.</a:t>
+              <a:t> Para atender às necessidades de comunicação e aproximação com o público, criamos uma plataforma digital que fortalece a presença do Instituto Alma e facilita sua interação com a comunidade. O site reúne informações institucionais de forma clara, apresenta suas ações e eventos e disponibiliza um espaço transparente sobre doações. Também inclui um canal de ouvidoria, promovendo diálogo e recebendo sugestões dos usuários, além de uma área administrativa que permite a atualização e gestão de conteúdos sem complexidade. Essa solução centraliza informações, amplia o alcance das iniciativas e contribui para a construção de uma imagem mais profissional e acessível do Instituto.</a:t>
             </a:r>
             <a:endParaRPr lang="pt-BR" sz="2666" dirty="0"/>
           </a:p>
@@ -5307,7 +5188,15 @@
             <a:pPr eaLnBrk="1" hangingPunct="1"/>
             <a:r>
               <a:rPr lang="pt-BR" sz="2666" b="1" kern="0" dirty="0"/>
-              <a:t>Professores: Francisco Escobar; Victor Rosseti Eduardo Savino; Ronaldo Araujo; José Carlos Buesso.</a:t>
+              <a:t>Professores: Francisco Escobar; </a:t>
+            </a:r>
+            <a:r>
+              <a:rPr lang="pt-BR" sz="2666" b="1" kern="0"/>
+              <a:t>Victor Rosetti; </a:t>
+            </a:r>
+            <a:r>
+              <a:rPr lang="pt-BR" sz="2666" b="1" kern="0" dirty="0"/>
+              <a:t>Eduardo Savino; Ronaldo Araujo; José Carlos Buesso.</a:t>
             </a:r>
             <a:endParaRPr lang="pt-BR" sz="5866" b="1" kern="0" dirty="0"/>
           </a:p>
@@ -5330,7 +5219,7 @@
         <p:spPr bwMode="auto">
           <a:xfrm>
             <a:off x="14646784" y="34849791"/>
-            <a:ext cx="13318910" cy="3067443"/>
+            <a:ext cx="13318910" cy="4339650"/>
           </a:xfrm>
           <a:prstGeom prst="rect">
             <a:avLst/>
@@ -5380,18 +5269,9 @@
               </a:spcAft>
             </a:pPr>
             <a:r>
-              <a:rPr lang="pt-BR" sz="3733" dirty="0"/>
-              <a:t> </a:t>
-            </a:r>
-            <a:r>
-              <a:rPr lang="pt-BR" sz="2666" dirty="0"/>
-              <a:t>	  </a:t>
-            </a:r>
-            <a:r>
               <a:rPr lang="pt-BR" sz="2400" dirty="0"/>
-              <a:t>O próximo passo é manter o site ativo para uso real do Instituto e, com isso, monitorar métricas para melhorias contínuas, baseadas no feedback dos usuários. Pretendemos integrar campanhas entre o site e as redes sociais para ampliar o alcance e engajamento. A evolução do projeto inclui aprimorar a acessibilidade e tornar a plataforma mais inclusiva. A continuidade do site permitirá ampliar o impacto social do Instituto e fortalecer sua conexão com a comunidade.</a:t>
-            </a:r>
-            <a:endParaRPr lang="pt-BR" sz="2666" dirty="0"/>
+              <a:t> 	 O próximo passo é manter o site em funcionamento e realizar pequenas atualizações periódicas para corrigir ajustes, melhorar a navegação e incluir novos conteúdos conforme o Instituto realizar atividades. Também pretendemos acompanhar o uso da plataforma por meio de feedbacks simples dos usuários, identificando melhorias que possam ser aplicadas em versões futuras. Além disso, planejamos ampliar a presença digital do Instituto com postagens e divulgações nas redes sociais, direcionando o público para o site e aumentando o engajamento de forma gradual. Outro ponto previsto é aprimorar alguns recursos já existentes, como a área de doações e a página de atividades, tornando-as mais intuitivas e informativas. Com essas ações, o projeto poderá evoluir de maneira contínua e sustentável, garantindo que o site permaneça útil, atualizado e alinhado às necessidades do Instituto e da comunidade.</a:t>
+            </a:r>
           </a:p>
         </p:txBody>
       </p:sp>
@@ -5411,7 +5291,7 @@
         </p:nvSpPr>
         <p:spPr bwMode="auto">
           <a:xfrm>
-            <a:off x="7895958" y="10999627"/>
+            <a:off x="7959431" y="10343748"/>
             <a:ext cx="12868819" cy="1569469"/>
           </a:xfrm>
           <a:prstGeom prst="rect">
@@ -5572,8 +5452,8 @@
         </p:blipFill>
         <p:spPr>
           <a:xfrm>
-            <a:off x="17171757" y="16432298"/>
-            <a:ext cx="2651482" cy="1369821"/>
+            <a:off x="6970948" y="12740511"/>
+            <a:ext cx="2414574" cy="1247428"/>
           </a:xfrm>
           <a:prstGeom prst="rect">
             <a:avLst/>
@@ -5608,8 +5488,8 @@
         </p:blipFill>
         <p:spPr>
           <a:xfrm>
-            <a:off x="8581768" y="12783152"/>
-            <a:ext cx="2390002" cy="2390002"/>
+            <a:off x="10075518" y="12767591"/>
+            <a:ext cx="1327482" cy="1327482"/>
           </a:xfrm>
           <a:prstGeom prst="rect">
             <a:avLst/>
@@ -5644,8 +5524,8 @@
         </p:blipFill>
         <p:spPr>
           <a:xfrm>
-            <a:off x="13503683" y="12741840"/>
-            <a:ext cx="1678276" cy="2369168"/>
+            <a:off x="12092996" y="12656267"/>
+            <a:ext cx="1019224" cy="1438806"/>
           </a:xfrm>
           <a:prstGeom prst="rect">
             <a:avLst/>
@@ -5680,8 +5560,8 @@
         </p:blipFill>
         <p:spPr>
           <a:xfrm>
-            <a:off x="13351746" y="16330480"/>
-            <a:ext cx="1969985" cy="1969985"/>
+            <a:off x="15663178" y="12629069"/>
+            <a:ext cx="1606334" cy="1606332"/>
           </a:xfrm>
           <a:prstGeom prst="rect">
             <a:avLst/>
@@ -5716,8 +5596,8 @@
         </p:blipFill>
         <p:spPr>
           <a:xfrm>
-            <a:off x="8880766" y="16406248"/>
-            <a:ext cx="2252785" cy="1689588"/>
+            <a:off x="19889667" y="12796111"/>
+            <a:ext cx="1737158" cy="1302866"/>
           </a:xfrm>
           <a:prstGeom prst="rect">
             <a:avLst/>
@@ -5752,8 +5632,8 @@
         </p:blipFill>
         <p:spPr>
           <a:xfrm>
-            <a:off x="17713872" y="13246767"/>
-            <a:ext cx="1567253" cy="1567253"/>
+            <a:off x="13802216" y="12810165"/>
+            <a:ext cx="1195992" cy="1195990"/>
           </a:xfrm>
           <a:prstGeom prst="rect">
             <a:avLst/>
@@ -5762,10 +5642,10 @@
       </p:pic>
       <p:pic>
         <p:nvPicPr>
-          <p:cNvPr id="9" name="Imagem 8" descr="Homem de barba posando para foto&#10;&#10;O conteúdo gerado por IA pode estar incorreto.">
+          <p:cNvPr id="19" name="Imagem 18" descr="Ícone&#10;&#10;O conteúdo gerado por IA pode estar incorreto.">
             <a:extLst>
               <a:ext uri="{FF2B5EF4-FFF2-40B4-BE49-F238E27FC236}">
-                <a16:creationId xmlns:a16="http://schemas.microsoft.com/office/drawing/2014/main" id="{2F5633EE-875C-27FB-36D6-D707B3965781}"/>
+                <a16:creationId xmlns:a16="http://schemas.microsoft.com/office/drawing/2014/main" id="{1652BFF4-CD39-4D8B-CDB6-2EEBEA3ABE34}"/>
               </a:ext>
             </a:extLst>
           </p:cNvPr>
@@ -5775,7 +5655,7 @@
           <p:nvPr/>
         </p:nvPicPr>
         <p:blipFill>
-          <a:blip r:embed="rId12">
+          <a:blip r:embed="rId12" cstate="print">
             <a:extLst>
               <a:ext uri="{28A0092B-C50C-407E-A947-70E740481C1C}">
                 <a14:useLocalDpi xmlns:a14="http://schemas.microsoft.com/office/drawing/2010/main" val="0"/>
@@ -5788,8 +5668,8 @@
         </p:blipFill>
         <p:spPr>
           <a:xfrm>
-            <a:off x="708195" y="5766540"/>
-            <a:ext cx="2130987" cy="2130987"/>
+            <a:off x="17934482" y="12610953"/>
+            <a:ext cx="1594416" cy="1594414"/>
           </a:xfrm>
           <a:prstGeom prst="rect">
             <a:avLst/>
@@ -5798,10 +5678,10 @@
       </p:pic>
       <p:pic>
         <p:nvPicPr>
-          <p:cNvPr id="20" name="Imagem 19" descr="Homem tirando foto de si mesmo em frente ao espelho&#10;&#10;O conteúdo gerado por IA pode estar incorreto.">
+          <p:cNvPr id="39" name="Imagem 38" descr="Interface gráfica do usuário, Site&#10;&#10;O conteúdo gerado por IA pode estar incorreto.">
             <a:extLst>
               <a:ext uri="{FF2B5EF4-FFF2-40B4-BE49-F238E27FC236}">
-                <a16:creationId xmlns:a16="http://schemas.microsoft.com/office/drawing/2014/main" id="{91AD46E0-7E4A-4BF4-4C3A-8FC981CEA3AF}"/>
+                <a16:creationId xmlns:a16="http://schemas.microsoft.com/office/drawing/2014/main" id="{47EC7B2E-1438-6CA5-CD4E-2C1A1D0E8A4D}"/>
               </a:ext>
             </a:extLst>
           </p:cNvPr>
@@ -5824,8 +5704,8 @@
         </p:blipFill>
         <p:spPr>
           <a:xfrm>
-            <a:off x="3580811" y="5797460"/>
-            <a:ext cx="2130986" cy="2130986"/>
+            <a:off x="873849" y="16538553"/>
+            <a:ext cx="12342882" cy="5886010"/>
           </a:xfrm>
           <a:prstGeom prst="rect">
             <a:avLst/>
@@ -5834,10 +5714,10 @@
       </p:pic>
       <p:pic>
         <p:nvPicPr>
-          <p:cNvPr id="23" name="Imagem 22" descr="Pessoa de cabelo curto sorrindo&#10;&#10;O conteúdo gerado por IA pode estar incorreto.">
+          <p:cNvPr id="24" name="Imagem 23" descr="Interface gráfica do usuário&#10;&#10;O conteúdo gerado por IA pode estar incorreto.">
             <a:extLst>
               <a:ext uri="{FF2B5EF4-FFF2-40B4-BE49-F238E27FC236}">
-                <a16:creationId xmlns:a16="http://schemas.microsoft.com/office/drawing/2014/main" id="{477B4CEF-8B65-BD40-07B4-86CACCB9200F}"/>
+                <a16:creationId xmlns:a16="http://schemas.microsoft.com/office/drawing/2014/main" id="{F2004384-96DB-EA09-D0EF-B0661EFA7B1C}"/>
               </a:ext>
             </a:extLst>
           </p:cNvPr>
@@ -5860,8 +5740,8 @@
         </p:blipFill>
         <p:spPr>
           <a:xfrm>
-            <a:off x="6450782" y="5805714"/>
-            <a:ext cx="2130986" cy="2130986"/>
+            <a:off x="14552840" y="16613496"/>
+            <a:ext cx="13565394" cy="5811067"/>
           </a:xfrm>
           <a:prstGeom prst="rect">
             <a:avLst/>
@@ -5870,10 +5750,10 @@
       </p:pic>
       <p:pic>
         <p:nvPicPr>
-          <p:cNvPr id="25" name="Imagem 24" descr="Homem de camisa preta&#10;&#10;O conteúdo gerado por IA pode estar incorreto.">
+          <p:cNvPr id="32" name="Imagem 31" descr="Interface gráfica do usuário, Texto, Aplicativo, Email&#10;&#10;O conteúdo gerado por IA pode estar incorreto.">
             <a:extLst>
               <a:ext uri="{FF2B5EF4-FFF2-40B4-BE49-F238E27FC236}">
-                <a16:creationId xmlns:a16="http://schemas.microsoft.com/office/drawing/2014/main" id="{B1787FF8-F3B8-5016-2E54-1D9A2AFE82AB}"/>
+                <a16:creationId xmlns:a16="http://schemas.microsoft.com/office/drawing/2014/main" id="{613634C8-BDB1-7310-58D3-404A9B6F74C6}"/>
               </a:ext>
             </a:extLst>
           </p:cNvPr>
@@ -5896,160 +5776,56 @@
         </p:blipFill>
         <p:spPr>
           <a:xfrm>
-            <a:off x="9329342" y="5797460"/>
-            <a:ext cx="2129339" cy="2129339"/>
+            <a:off x="2329126" y="24760910"/>
+            <a:ext cx="9921364" cy="7017168"/>
           </a:xfrm>
           <a:prstGeom prst="rect">
             <a:avLst/>
           </a:prstGeom>
         </p:spPr>
       </p:pic>
-      <p:sp>
-        <p:nvSpPr>
-          <p:cNvPr id="27" name="CaixaDeTexto 26">
+      <p:pic>
+        <p:nvPicPr>
+          <p:cNvPr id="34" name="Imagem 33" descr="Logotipo&#10;&#10;O conteúdo gerado por IA pode estar incorreto.">
             <a:extLst>
               <a:ext uri="{FF2B5EF4-FFF2-40B4-BE49-F238E27FC236}">
-                <a16:creationId xmlns:a16="http://schemas.microsoft.com/office/drawing/2014/main" id="{F9DE6C96-A6AC-EE22-5AB3-2A0A39CD0BF5}"/>
+                <a16:creationId xmlns:a16="http://schemas.microsoft.com/office/drawing/2014/main" id="{9E7FDCD3-D33A-A6FE-C2B8-AA4BA081B2AC}"/>
               </a:ext>
             </a:extLst>
           </p:cNvPr>
-          <p:cNvSpPr txBox="1"/>
+          <p:cNvPicPr>
+            <a:picLocks noChangeAspect="1"/>
+          </p:cNvPicPr>
           <p:nvPr/>
-        </p:nvSpPr>
+        </p:nvPicPr>
+        <p:blipFill>
+          <a:blip r:embed="rId16">
+            <a:extLst>
+              <a:ext uri="{28A0092B-C50C-407E-A947-70E740481C1C}">
+                <a14:useLocalDpi xmlns:a14="http://schemas.microsoft.com/office/drawing/2010/main" val="0"/>
+              </a:ext>
+            </a:extLst>
+          </a:blip>
+          <a:stretch>
+            <a:fillRect/>
+          </a:stretch>
+        </p:blipFill>
         <p:spPr>
           <a:xfrm>
-            <a:off x="827369" y="8155494"/>
-            <a:ext cx="2596651" cy="461665"/>
+            <a:off x="16495481" y="24620539"/>
+            <a:ext cx="10262688" cy="7297910"/>
           </a:xfrm>
           <a:prstGeom prst="rect">
             <a:avLst/>
           </a:prstGeom>
-          <a:noFill/>
-        </p:spPr>
-        <p:txBody>
-          <a:bodyPr wrap="square" rtlCol="0">
-            <a:spAutoFit/>
-          </a:bodyPr>
-          <a:lstStyle/>
-          <a:p>
-            <a:r>
-              <a:rPr lang="pt-BR" sz="2400" dirty="0"/>
-              <a:t>Enzo Ribeiro</a:t>
-            </a:r>
-          </a:p>
-        </p:txBody>
-      </p:sp>
-      <p:sp>
-        <p:nvSpPr>
-          <p:cNvPr id="28" name="CaixaDeTexto 27">
+        </p:spPr>
+      </p:pic>
+      <p:sp>
+        <p:nvSpPr>
+          <p:cNvPr id="38" name="TextBox 8">
             <a:extLst>
               <a:ext uri="{FF2B5EF4-FFF2-40B4-BE49-F238E27FC236}">
-                <a16:creationId xmlns:a16="http://schemas.microsoft.com/office/drawing/2014/main" id="{4EFC1E5D-2DD7-D82A-7F8A-A7903761A934}"/>
-              </a:ext>
-            </a:extLst>
-          </p:cNvPr>
-          <p:cNvSpPr txBox="1"/>
-          <p:nvPr/>
-        </p:nvSpPr>
-        <p:spPr>
-          <a:xfrm>
-            <a:off x="3424020" y="8155495"/>
-            <a:ext cx="2596651" cy="461665"/>
-          </a:xfrm>
-          <a:prstGeom prst="rect">
-            <a:avLst/>
-          </a:prstGeom>
-          <a:noFill/>
-        </p:spPr>
-        <p:txBody>
-          <a:bodyPr wrap="square" rtlCol="0">
-            <a:spAutoFit/>
-          </a:bodyPr>
-          <a:lstStyle/>
-          <a:p>
-            <a:r>
-              <a:rPr lang="pt-BR" sz="2400" dirty="0"/>
-              <a:t>Rikelmy Anacleto</a:t>
-            </a:r>
-          </a:p>
-        </p:txBody>
-      </p:sp>
-      <p:sp>
-        <p:nvSpPr>
-          <p:cNvPr id="30" name="CaixaDeTexto 29">
-            <a:extLst>
-              <a:ext uri="{FF2B5EF4-FFF2-40B4-BE49-F238E27FC236}">
-                <a16:creationId xmlns:a16="http://schemas.microsoft.com/office/drawing/2014/main" id="{1FD3AF51-EADC-FC07-52DA-E72DACA275EA}"/>
-              </a:ext>
-            </a:extLst>
-          </p:cNvPr>
-          <p:cNvSpPr txBox="1"/>
-          <p:nvPr/>
-        </p:nvSpPr>
-        <p:spPr>
-          <a:xfrm>
-            <a:off x="6412486" y="8155538"/>
-            <a:ext cx="2596651" cy="461665"/>
-          </a:xfrm>
-          <a:prstGeom prst="rect">
-            <a:avLst/>
-          </a:prstGeom>
-          <a:noFill/>
-        </p:spPr>
-        <p:txBody>
-          <a:bodyPr wrap="square" rtlCol="0">
-            <a:spAutoFit/>
-          </a:bodyPr>
-          <a:lstStyle/>
-          <a:p>
-            <a:r>
-              <a:rPr lang="pt-BR" sz="2400" dirty="0"/>
-              <a:t>Matheus Andreo</a:t>
-            </a:r>
-          </a:p>
-        </p:txBody>
-      </p:sp>
-      <p:sp>
-        <p:nvSpPr>
-          <p:cNvPr id="31" name="CaixaDeTexto 30">
-            <a:extLst>
-              <a:ext uri="{FF2B5EF4-FFF2-40B4-BE49-F238E27FC236}">
-                <a16:creationId xmlns:a16="http://schemas.microsoft.com/office/drawing/2014/main" id="{0D0724BD-1D7D-34F2-0E2E-AAB0D51D3A3D}"/>
-              </a:ext>
-            </a:extLst>
-          </p:cNvPr>
-          <p:cNvSpPr txBox="1"/>
-          <p:nvPr/>
-        </p:nvSpPr>
-        <p:spPr>
-          <a:xfrm>
-            <a:off x="9296179" y="8155496"/>
-            <a:ext cx="2596651" cy="461665"/>
-          </a:xfrm>
-          <a:prstGeom prst="rect">
-            <a:avLst/>
-          </a:prstGeom>
-          <a:noFill/>
-        </p:spPr>
-        <p:txBody>
-          <a:bodyPr wrap="square" rtlCol="0">
-            <a:spAutoFit/>
-          </a:bodyPr>
-          <a:lstStyle/>
-          <a:p>
-            <a:r>
-              <a:rPr lang="pt-BR" sz="2400" dirty="0"/>
-              <a:t>Lucas Camargo</a:t>
-            </a:r>
-          </a:p>
-        </p:txBody>
-      </p:sp>
-      <p:sp>
-        <p:nvSpPr>
-          <p:cNvPr id="35" name="TextBox 8">
-            <a:extLst>
-              <a:ext uri="{FF2B5EF4-FFF2-40B4-BE49-F238E27FC236}">
-                <a16:creationId xmlns:a16="http://schemas.microsoft.com/office/drawing/2014/main" id="{833FE777-126C-65F4-4FBD-F2F4E06331ED}"/>
+                <a16:creationId xmlns:a16="http://schemas.microsoft.com/office/drawing/2014/main" id="{E7416FEB-3776-3D09-AC3F-C74620691E78}"/>
               </a:ext>
             </a:extLst>
           </p:cNvPr>
@@ -6060,8 +5836,8 @@
         </p:nvSpPr>
         <p:spPr bwMode="auto">
           <a:xfrm>
-            <a:off x="630353" y="8987834"/>
-            <a:ext cx="13284851" cy="830997"/>
+            <a:off x="873849" y="4992305"/>
+            <a:ext cx="13284851" cy="5078313"/>
           </a:xfrm>
           <a:prstGeom prst="rect">
             <a:avLst/>
@@ -6098,159 +5874,25 @@
           <a:p>
             <a:pPr algn="just" defTabSz="1678349" eaLnBrk="1" hangingPunct="1"/>
             <a:r>
+              <a:rPr lang="pt-BR" sz="3600" b="1" dirty="0">
+                <a:ea typeface="ＭＳ Ｐゴシック" pitchFamily="34" charset="-128"/>
+              </a:rPr>
+              <a:t>Sobre a equipe</a:t>
+            </a:r>
+          </a:p>
+          <a:p>
+            <a:pPr algn="just" defTabSz="1678349" eaLnBrk="1" hangingPunct="1">
+              <a:spcAft>
+                <a:spcPts val="1200"/>
+              </a:spcAft>
+            </a:pPr>
+            <a:r>
               <a:rPr lang="pt-BR" sz="2400" dirty="0"/>
-              <a:t>Todo o projeto foi desenvolvido de forma colaborativa, com cada membro da equipe contribuindo igualmente em todas as etapas, garantindo que o resultado final fosse fruto do esforço conjunto.</a:t>
-            </a:r>
-            <a:endParaRPr lang="pt-BR" sz="2400" dirty="0">
-              <a:ea typeface="ＭＳ Ｐゴシック" pitchFamily="34" charset="-128"/>
-            </a:endParaRPr>
-          </a:p>
-        </p:txBody>
-      </p:sp>
-      <p:pic>
-        <p:nvPicPr>
-          <p:cNvPr id="39" name="Imagem 38" descr="Interface gráfica do usuário, Site&#10;&#10;O conteúdo gerado por IA pode estar incorreto.">
-            <a:extLst>
-              <a:ext uri="{FF2B5EF4-FFF2-40B4-BE49-F238E27FC236}">
-                <a16:creationId xmlns:a16="http://schemas.microsoft.com/office/drawing/2014/main" id="{47EC7B2E-1438-6CA5-CD4E-2C1A1D0E8A4D}"/>
-              </a:ext>
-            </a:extLst>
-          </p:cNvPr>
-          <p:cNvPicPr>
-            <a:picLocks noChangeAspect="1"/>
-          </p:cNvPicPr>
-          <p:nvPr/>
-        </p:nvPicPr>
-        <p:blipFill>
-          <a:blip r:embed="rId16">
-            <a:extLst>
-              <a:ext uri="{28A0092B-C50C-407E-A947-70E740481C1C}">
-                <a14:useLocalDpi xmlns:a14="http://schemas.microsoft.com/office/drawing/2010/main" val="0"/>
-              </a:ext>
-            </a:extLst>
-          </a:blip>
-          <a:stretch>
-            <a:fillRect/>
-          </a:stretch>
-        </p:blipFill>
-        <p:spPr>
-          <a:xfrm>
-            <a:off x="1974363" y="19379889"/>
-            <a:ext cx="10530618" cy="5021788"/>
-          </a:xfrm>
-          <a:prstGeom prst="rect">
-            <a:avLst/>
-          </a:prstGeom>
-        </p:spPr>
-      </p:pic>
-      <p:pic>
-        <p:nvPicPr>
-          <p:cNvPr id="41" name="Imagem 40" descr="Interface gráfica do usuário, Site&#10;&#10;O conteúdo gerado por IA pode estar incorreto.">
-            <a:extLst>
-              <a:ext uri="{FF2B5EF4-FFF2-40B4-BE49-F238E27FC236}">
-                <a16:creationId xmlns:a16="http://schemas.microsoft.com/office/drawing/2014/main" id="{34C11D19-B776-08FA-8D71-EC325ABF08D1}"/>
-              </a:ext>
-            </a:extLst>
-          </p:cNvPr>
-          <p:cNvPicPr>
-            <a:picLocks noChangeAspect="1"/>
-          </p:cNvPicPr>
-          <p:nvPr/>
-        </p:nvPicPr>
-        <p:blipFill>
-          <a:blip r:embed="rId17">
-            <a:extLst>
-              <a:ext uri="{28A0092B-C50C-407E-A947-70E740481C1C}">
-                <a14:useLocalDpi xmlns:a14="http://schemas.microsoft.com/office/drawing/2010/main" val="0"/>
-              </a:ext>
-            </a:extLst>
-          </a:blip>
-          <a:stretch>
-            <a:fillRect/>
-          </a:stretch>
-        </p:blipFill>
-        <p:spPr>
-          <a:xfrm>
-            <a:off x="15588324" y="26238427"/>
-            <a:ext cx="10058400" cy="7677150"/>
-          </a:xfrm>
-          <a:prstGeom prst="rect">
-            <a:avLst/>
-          </a:prstGeom>
-        </p:spPr>
-      </p:pic>
-      <p:pic>
-        <p:nvPicPr>
-          <p:cNvPr id="43" name="Imagem 42" descr="Uma imagem contendo Logotipo&#10;&#10;O conteúdo gerado por IA pode estar incorreto.">
-            <a:extLst>
-              <a:ext uri="{FF2B5EF4-FFF2-40B4-BE49-F238E27FC236}">
-                <a16:creationId xmlns:a16="http://schemas.microsoft.com/office/drawing/2014/main" id="{89F40BDF-BBD6-AB2A-4AFA-121BD6878340}"/>
-              </a:ext>
-            </a:extLst>
-          </p:cNvPr>
-          <p:cNvPicPr>
-            <a:picLocks noChangeAspect="1"/>
-          </p:cNvPicPr>
-          <p:nvPr/>
-        </p:nvPicPr>
-        <p:blipFill>
-          <a:blip r:embed="rId18">
-            <a:extLst>
-              <a:ext uri="{28A0092B-C50C-407E-A947-70E740481C1C}">
-                <a14:useLocalDpi xmlns:a14="http://schemas.microsoft.com/office/drawing/2010/main" val="0"/>
-              </a:ext>
-            </a:extLst>
-          </a:blip>
-          <a:stretch>
-            <a:fillRect/>
-          </a:stretch>
-        </p:blipFill>
-        <p:spPr>
-          <a:xfrm>
-            <a:off x="16844811" y="19501574"/>
-            <a:ext cx="7545426" cy="4950440"/>
-          </a:xfrm>
-          <a:prstGeom prst="rect">
-            <a:avLst/>
-          </a:prstGeom>
-        </p:spPr>
-      </p:pic>
-      <p:pic>
-        <p:nvPicPr>
-          <p:cNvPr id="45" name="Imagem 44" descr="Logotipo&#10;&#10;O conteúdo gerado por IA pode estar incorreto.">
-            <a:extLst>
-              <a:ext uri="{FF2B5EF4-FFF2-40B4-BE49-F238E27FC236}">
-                <a16:creationId xmlns:a16="http://schemas.microsoft.com/office/drawing/2014/main" id="{3A7CD76A-527F-6733-744A-F5AB970881FC}"/>
-              </a:ext>
-            </a:extLst>
-          </p:cNvPr>
-          <p:cNvPicPr>
-            <a:picLocks noChangeAspect="1"/>
-          </p:cNvPicPr>
-          <p:nvPr/>
-        </p:nvPicPr>
-        <p:blipFill>
-          <a:blip r:embed="rId19">
-            <a:extLst>
-              <a:ext uri="{28A0092B-C50C-407E-A947-70E740481C1C}">
-                <a14:useLocalDpi xmlns:a14="http://schemas.microsoft.com/office/drawing/2010/main" val="0"/>
-              </a:ext>
-            </a:extLst>
-          </a:blip>
-          <a:stretch>
-            <a:fillRect/>
-          </a:stretch>
-        </p:blipFill>
-        <p:spPr>
-          <a:xfrm>
-            <a:off x="2766605" y="26246602"/>
-            <a:ext cx="9012346" cy="6408778"/>
-          </a:xfrm>
-          <a:prstGeom prst="rect">
-            <a:avLst/>
-          </a:prstGeom>
-        </p:spPr>
-      </p:pic>
+              <a:t> 	  A construção deste projeto foi resultado de um trabalho totalmente colaborativo, no qual cada integrante da equipe participou ativamente de todas as etapas do desenvolvimento. Desde o planejamento inicial, definição de requisitos e pesquisa sobre o Instituto Alma, até o design, criação do conteúdo, programação e testes finais, todas as decisões foram tomadas de forma conjunta. Valorizamos a troca de ideias, o aprendizado coletivo e o apoio mútuo, garantindo que cada membro contribuísse de maneira igual para o sucesso do projeto. Esse trabalho em equipe reforçou a importância da comunicação, organização e comprometimento, permitindo que uníssemos habilidades e perspectivas diferentes para alcançar um resultado completo, funcional e alinhado ao propósito social do Instituto. O projeto não apenas fortaleceu nosso conhecimento técnico, mas também desenvolveu nossa capacidade de trabalhar em equipe, refletindo um trabalho realmente conjunto, onde todos contribuíram com o mesmo comprometimento.	</a:t>
+            </a:r>
+          </a:p>
+        </p:txBody>
+      </p:sp>
     </p:spTree>
     <p:extLst>
       <p:ext uri="{BB962C8B-B14F-4D97-AF65-F5344CB8AC3E}">
@@ -7674,6 +7316,15 @@
 </file>
 
 <file path=customXml/item1.xml><?xml version="1.0" encoding="utf-8"?>
+<?mso-contentType ?>
+<FormTemplates xmlns="http://schemas.microsoft.com/sharepoint/v3/contenttype/forms">
+  <Display>DocumentLibraryForm</Display>
+  <Edit>DocumentLibraryForm</Edit>
+  <New>DocumentLibraryForm</New>
+</FormTemplates>
+</file>
+
+<file path=customXml/item2.xml><?xml version="1.0" encoding="utf-8"?>
 <p:properties xmlns:p="http://schemas.microsoft.com/office/2006/metadata/properties" xmlns:xsi="http://www.w3.org/2001/XMLSchema-instance" xmlns:pc="http://schemas.microsoft.com/office/infopath/2007/PartnerControls">
   <documentManagement>
     <lcf76f155ced4ddcb4097134ff3c332f xmlns="8ca2a57e-8138-4b57-956a-eb6e2c7049cc">
@@ -7682,15 +7333,6 @@
     <TaxCatchAll xmlns="1d2798d9-1030-4cc5-be7b-200f9e628651" xsi:nil="true"/>
   </documentManagement>
 </p:properties>
-</file>
-
-<file path=customXml/item2.xml><?xml version="1.0" encoding="utf-8"?>
-<?mso-contentType ?>
-<FormTemplates xmlns="http://schemas.microsoft.com/sharepoint/v3/contenttype/forms">
-  <Display>DocumentLibraryForm</Display>
-  <Edit>DocumentLibraryForm</Edit>
-  <New>DocumentLibraryForm</New>
-</FormTemplates>
 </file>
 
 <file path=customXml/item3.xml><?xml version="1.0" encoding="utf-8"?>
@@ -7929,6 +7571,14 @@
 </file>
 
 <file path=customXml/itemProps1.xml><?xml version="1.0" encoding="utf-8"?>
+<ds:datastoreItem xmlns:ds="http://schemas.openxmlformats.org/officeDocument/2006/customXml" ds:itemID="{20511531-72C6-41EA-909D-35A50B0891E1}">
+  <ds:schemaRefs>
+    <ds:schemaRef ds:uri="http://schemas.microsoft.com/sharepoint/v3/contenttype/forms"/>
+  </ds:schemaRefs>
+</ds:datastoreItem>
+</file>
+
+<file path=customXml/itemProps2.xml><?xml version="1.0" encoding="utf-8"?>
 <ds:datastoreItem xmlns:ds="http://schemas.openxmlformats.org/officeDocument/2006/customXml" ds:itemID="{8C580D08-C850-4D98-9BB0-6190D1509D8A}">
   <ds:schemaRefs>
     <ds:schemaRef ds:uri="http://www.w3.org/XML/1998/namespace"/>
@@ -7941,14 +7591,6 @@
     <ds:schemaRef ds:uri="http://schemas.openxmlformats.org/package/2006/metadata/core-properties"/>
     <ds:schemaRef ds:uri="8ca2a57e-8138-4b57-956a-eb6e2c7049cc"/>
     <ds:schemaRef ds:uri="http://purl.org/dc/terms/"/>
-  </ds:schemaRefs>
-</ds:datastoreItem>
-</file>
-
-<file path=customXml/itemProps2.xml><?xml version="1.0" encoding="utf-8"?>
-<ds:datastoreItem xmlns:ds="http://schemas.openxmlformats.org/officeDocument/2006/customXml" ds:itemID="{20511531-72C6-41EA-909D-35A50B0891E1}">
-  <ds:schemaRefs>
-    <ds:schemaRef ds:uri="http://schemas.microsoft.com/sharepoint/v3/contenttype/forms"/>
   </ds:schemaRefs>
 </ds:datastoreItem>
 </file>

</xml_diff>